<commit_message>
Opto Udate / Intro
</commit_message>
<xml_diff>
--- a/OptoElectronique/Cours/S5_Optoelectronique_2026_lite.pptx
+++ b/OptoElectronique/Cours/S5_Optoelectronique_2026_lite.pptx
@@ -10759,64 +10759,6 @@
           </a:prstGeom>
         </p:spPr>
       </p:pic>
-      <p:sp>
-        <p:nvSpPr>
-          <p:cNvPr id="25" name="Rectangle : coins arrondis 13">
-            <a:extLst>
-              <a:ext uri="{FF2B5EF4-FFF2-40B4-BE49-F238E27FC236}">
-                <a16:creationId xmlns:a16="http://schemas.microsoft.com/office/drawing/2014/main" id="{81E8FF1F-0D52-122D-E5E6-DAD7AD83E1F7}"/>
-              </a:ext>
-            </a:extLst>
-          </p:cNvPr>
-          <p:cNvSpPr/>
-          <p:nvPr/>
-        </p:nvSpPr>
-        <p:spPr>
-          <a:xfrm>
-            <a:off x="743266" y="1977914"/>
-            <a:ext cx="6680760" cy="598770"/>
-          </a:xfrm>
-          <a:prstGeom prst="roundRect">
-            <a:avLst>
-              <a:gd name="adj" fmla="val 46546"/>
-            </a:avLst>
-          </a:prstGeom>
-          <a:solidFill>
-            <a:srgbClr val="002060"/>
-          </a:solidFill>
-          <a:ln>
-            <a:noFill/>
-          </a:ln>
-        </p:spPr>
-        <p:style>
-          <a:lnRef idx="2">
-            <a:schemeClr val="accent1">
-              <a:shade val="15000"/>
-            </a:schemeClr>
-          </a:lnRef>
-          <a:fillRef idx="1">
-            <a:schemeClr val="accent1"/>
-          </a:fillRef>
-          <a:effectRef idx="0">
-            <a:schemeClr val="accent1"/>
-          </a:effectRef>
-          <a:fontRef idx="minor">
-            <a:schemeClr val="lt1"/>
-          </a:fontRef>
-        </p:style>
-        <p:txBody>
-          <a:bodyPr rtlCol="0" anchor="ctr"/>
-          <a:lstStyle/>
-          <a:p>
-            <a:pPr algn="ctr"/>
-            <a:r>
-              <a:rPr lang="fr-FR" dirty="0"/>
-              <a:t>Comment acquérir un signal lumineux ?</a:t>
-            </a:r>
-            <a:endParaRPr lang="fr-FR" sz="2400" dirty="0"/>
-          </a:p>
-        </p:txBody>
-      </p:sp>
       <p:pic>
         <p:nvPicPr>
           <p:cNvPr id="26" name="Image 25"/>

</xml_diff>

<commit_message>
Update Opto / Intro / Ressources PyCharm
</commit_message>
<xml_diff>
--- a/OptoElectronique/Cours/S5_Optoelectronique_2026_lite.pptx
+++ b/OptoElectronique/Cours/S5_Optoelectronique_2026_lite.pptx
@@ -219,7 +219,7 @@
           <a:p>
             <a:fld id="{729C724E-499D-43AC-8699-CF969D2466FC}" type="datetimeFigureOut">
               <a:rPr lang="fr-FR" smtClean="0"/>
-              <a:t>03/09/2026</a:t>
+              <a:t>04/09/2026</a:t>
             </a:fld>
             <a:endParaRPr lang="fr-FR"/>
           </a:p>
@@ -1323,7 +1323,7 @@
           <a:p>
             <a:fld id="{02AC24A9-CCB6-4F8D-B8DB-C2F3692CFA5A}" type="datetimeFigureOut">
               <a:rPr lang="en-US" smtClean="0"/>
-              <a:t>9/3/2026</a:t>
+              <a:t>9/4/2026</a:t>
             </a:fld>
             <a:endParaRPr lang="en-US" dirty="0"/>
           </a:p>
@@ -1693,7 +1693,7 @@
           <a:p>
             <a:fld id="{02AC24A9-CCB6-4F8D-B8DB-C2F3692CFA5A}" type="datetimeFigureOut">
               <a:rPr lang="en-US" smtClean="0"/>
-              <a:t>9/3/2026</a:t>
+              <a:t>9/4/2026</a:t>
             </a:fld>
             <a:endParaRPr lang="en-US"/>
           </a:p>
@@ -1902,7 +1902,7 @@
           <a:p>
             <a:fld id="{02AC24A9-CCB6-4F8D-B8DB-C2F3692CFA5A}" type="datetimeFigureOut">
               <a:rPr lang="en-US" smtClean="0"/>
-              <a:t>9/3/2026</a:t>
+              <a:t>9/4/2026</a:t>
             </a:fld>
             <a:endParaRPr lang="en-US"/>
           </a:p>
@@ -2372,7 +2372,7 @@
           <a:p>
             <a:fld id="{02AC24A9-CCB6-4F8D-B8DB-C2F3692CFA5A}" type="datetimeFigureOut">
               <a:rPr lang="en-US" smtClean="0"/>
-              <a:t>9/3/2026</a:t>
+              <a:t>9/4/2026</a:t>
             </a:fld>
             <a:endParaRPr lang="en-US"/>
           </a:p>
@@ -2826,7 +2826,7 @@
           <a:p>
             <a:fld id="{02AC24A9-CCB6-4F8D-B8DB-C2F3692CFA5A}" type="datetimeFigureOut">
               <a:rPr lang="en-US" smtClean="0"/>
-              <a:t>9/3/2026</a:t>
+              <a:t>9/4/2026</a:t>
             </a:fld>
             <a:endParaRPr lang="en-US"/>
           </a:p>
@@ -3358,7 +3358,7 @@
           <a:p>
             <a:fld id="{02AC24A9-CCB6-4F8D-B8DB-C2F3692CFA5A}" type="datetimeFigureOut">
               <a:rPr lang="en-US" smtClean="0"/>
-              <a:t>9/3/2026</a:t>
+              <a:t>9/4/2026</a:t>
             </a:fld>
             <a:endParaRPr lang="en-US"/>
           </a:p>
@@ -4057,7 +4057,7 @@
           <a:p>
             <a:fld id="{02AC24A9-CCB6-4F8D-B8DB-C2F3692CFA5A}" type="datetimeFigureOut">
               <a:rPr lang="en-US" smtClean="0"/>
-              <a:t>9/3/2026</a:t>
+              <a:t>9/4/2026</a:t>
             </a:fld>
             <a:endParaRPr lang="en-US"/>
           </a:p>
@@ -4386,7 +4386,7 @@
           <a:p>
             <a:fld id="{02AC24A9-CCB6-4F8D-B8DB-C2F3692CFA5A}" type="datetimeFigureOut">
               <a:rPr lang="en-US" smtClean="0"/>
-              <a:t>9/3/2026</a:t>
+              <a:t>9/4/2026</a:t>
             </a:fld>
             <a:endParaRPr lang="en-US"/>
           </a:p>
@@ -4499,7 +4499,7 @@
           <a:p>
             <a:fld id="{02AC24A9-CCB6-4F8D-B8DB-C2F3692CFA5A}" type="datetimeFigureOut">
               <a:rPr lang="en-US" smtClean="0"/>
-              <a:t>9/3/2026</a:t>
+              <a:t>9/4/2026</a:t>
             </a:fld>
             <a:endParaRPr lang="en-US"/>
           </a:p>
@@ -4994,7 +4994,7 @@
           <a:p>
             <a:fld id="{02AC24A9-CCB6-4F8D-B8DB-C2F3692CFA5A}" type="datetimeFigureOut">
               <a:rPr lang="en-US" smtClean="0"/>
-              <a:t>9/3/2026</a:t>
+              <a:t>9/4/2026</a:t>
             </a:fld>
             <a:endParaRPr lang="en-US" dirty="0"/>
           </a:p>
@@ -5471,7 +5471,7 @@
           <a:p>
             <a:fld id="{02AC24A9-CCB6-4F8D-B8DB-C2F3692CFA5A}" type="datetimeFigureOut">
               <a:rPr lang="en-US" smtClean="0"/>
-              <a:t>9/3/2026</a:t>
+              <a:t>9/4/2026</a:t>
             </a:fld>
             <a:endParaRPr lang="en-US"/>
           </a:p>
@@ -5714,7 +5714,7 @@
           <a:p>
             <a:fld id="{02AC24A9-CCB6-4F8D-B8DB-C2F3692CFA5A}" type="datetimeFigureOut">
               <a:rPr lang="en-US" smtClean="0"/>
-              <a:t>9/3/2026</a:t>
+              <a:t>9/4/2026</a:t>
             </a:fld>
             <a:endParaRPr lang="en-US"/>
           </a:p>
@@ -12341,7 +12341,7 @@
           <a:p>
             <a:r>
               <a:rPr lang="fr-FR" dirty="0"/>
-              <a:t>4 séances</a:t>
+              <a:t>3 séances</a:t>
             </a:r>
           </a:p>
         </p:txBody>
@@ -12445,7 +12445,7 @@
             <a:pPr algn="ctr"/>
             <a:r>
               <a:rPr lang="fr-FR" sz="1600" b="1" dirty="0"/>
-              <a:t>2 séances en binôme</a:t>
+              <a:t>1 séance en binôme</a:t>
             </a:r>
           </a:p>
         </p:txBody>
@@ -14134,7 +14134,7 @@
             <a:pPr algn="ctr"/>
             <a:r>
               <a:rPr lang="fr-FR" sz="1600" b="1" dirty="0"/>
-              <a:t>TP4</a:t>
+              <a:t>Atelier Groupe</a:t>
             </a:r>
           </a:p>
         </p:txBody>
@@ -14153,8 +14153,8 @@
         </p:nvSpPr>
         <p:spPr>
           <a:xfrm>
-            <a:off x="3134746" y="2513900"/>
-            <a:ext cx="1604804" cy="350520"/>
+            <a:off x="3134747" y="2513900"/>
+            <a:ext cx="751454" cy="350520"/>
           </a:xfrm>
           <a:prstGeom prst="rect">
             <a:avLst/>
@@ -14188,7 +14188,7 @@
           <a:p>
             <a:pPr algn="ctr"/>
             <a:r>
-              <a:rPr lang="fr-FR" sz="1600" b="1" dirty="0"/>
+              <a:rPr lang="fr-FR" sz="1400" b="1" dirty="0"/>
               <a:t>TP VI1</a:t>
             </a:r>
           </a:p>
@@ -14196,10 +14196,10 @@
       </p:sp>
       <p:sp>
         <p:nvSpPr>
-          <p:cNvPr id="12" name="Rectangle 11">
-            <a:extLst>
-              <a:ext uri="{FF2B5EF4-FFF2-40B4-BE49-F238E27FC236}">
-                <a16:creationId xmlns:a16="http://schemas.microsoft.com/office/drawing/2014/main" id="{98EC2F02-6D26-E0A5-D033-44346437C756}"/>
+          <p:cNvPr id="18" name="Rectangle 17">
+            <a:extLst>
+              <a:ext uri="{FF2B5EF4-FFF2-40B4-BE49-F238E27FC236}">
+                <a16:creationId xmlns:a16="http://schemas.microsoft.com/office/drawing/2014/main" id="{67DB11C6-E438-64D0-8289-EA27977E12F7}"/>
               </a:ext>
             </a:extLst>
           </p:cNvPr>
@@ -14208,14 +14208,14 @@
         </p:nvSpPr>
         <p:spPr>
           <a:xfrm>
-            <a:off x="3134746" y="2891111"/>
+            <a:off x="3134746" y="3402867"/>
             <a:ext cx="1604804" cy="350520"/>
           </a:xfrm>
           <a:prstGeom prst="rect">
             <a:avLst/>
           </a:prstGeom>
           <a:solidFill>
-            <a:schemeClr val="accent2"/>
+            <a:srgbClr val="002060"/>
           </a:solidFill>
           <a:ln>
             <a:noFill/>
@@ -14244,17 +14244,17 @@
             <a:pPr algn="ctr"/>
             <a:r>
               <a:rPr lang="fr-FR" sz="1600" b="1" dirty="0"/>
-              <a:t>TP VI2</a:t>
-            </a:r>
-          </a:p>
-        </p:txBody>
-      </p:sp>
-      <p:sp>
-        <p:nvSpPr>
-          <p:cNvPr id="13" name="Rectangle 12">
-            <a:extLst>
-              <a:ext uri="{FF2B5EF4-FFF2-40B4-BE49-F238E27FC236}">
-                <a16:creationId xmlns:a16="http://schemas.microsoft.com/office/drawing/2014/main" id="{9FFE6914-2A73-DFF5-83B2-EC5F2562B15F}"/>
+              <a:t>TP1</a:t>
+            </a:r>
+          </a:p>
+        </p:txBody>
+      </p:sp>
+      <p:sp>
+        <p:nvSpPr>
+          <p:cNvPr id="24" name="Rectangle 23">
+            <a:extLst>
+              <a:ext uri="{FF2B5EF4-FFF2-40B4-BE49-F238E27FC236}">
+                <a16:creationId xmlns:a16="http://schemas.microsoft.com/office/drawing/2014/main" id="{5890B81A-9B60-BD6E-D526-CE952E97E6D8}"/>
               </a:ext>
             </a:extLst>
           </p:cNvPr>
@@ -14263,14 +14263,14 @@
         </p:nvSpPr>
         <p:spPr>
           <a:xfrm>
-            <a:off x="1354395" y="3408647"/>
+            <a:off x="3134746" y="3780078"/>
             <a:ext cx="1604804" cy="350520"/>
           </a:xfrm>
           <a:prstGeom prst="rect">
             <a:avLst/>
           </a:prstGeom>
           <a:solidFill>
-            <a:schemeClr val="accent2"/>
+            <a:srgbClr val="002060"/>
           </a:solidFill>
           <a:ln>
             <a:noFill/>
@@ -14299,17 +14299,335 @@
             <a:pPr algn="ctr"/>
             <a:r>
               <a:rPr lang="fr-FR" sz="1600" b="1" dirty="0"/>
-              <a:t>TP VI1</a:t>
-            </a:r>
-          </a:p>
-        </p:txBody>
-      </p:sp>
-      <p:sp>
-        <p:nvSpPr>
-          <p:cNvPr id="14" name="Rectangle 13">
-            <a:extLst>
-              <a:ext uri="{FF2B5EF4-FFF2-40B4-BE49-F238E27FC236}">
-                <a16:creationId xmlns:a16="http://schemas.microsoft.com/office/drawing/2014/main" id="{BD4D7028-BE06-8D91-89A4-291033DAED4D}"/>
+              <a:t>TP2</a:t>
+            </a:r>
+          </a:p>
+        </p:txBody>
+      </p:sp>
+      <p:sp>
+        <p:nvSpPr>
+          <p:cNvPr id="26" name="ZoneTexte 25">
+            <a:extLst>
+              <a:ext uri="{FF2B5EF4-FFF2-40B4-BE49-F238E27FC236}">
+                <a16:creationId xmlns:a16="http://schemas.microsoft.com/office/drawing/2014/main" id="{8604DACB-DF23-40CE-1944-F1D33C96E0FF}"/>
+              </a:ext>
+            </a:extLst>
+          </p:cNvPr>
+          <p:cNvSpPr txBox="1"/>
+          <p:nvPr/>
+        </p:nvSpPr>
+        <p:spPr>
+          <a:xfrm>
+            <a:off x="1354394" y="2077435"/>
+            <a:ext cx="1604804" cy="369332"/>
+          </a:xfrm>
+          <a:prstGeom prst="rect">
+            <a:avLst/>
+          </a:prstGeom>
+          <a:noFill/>
+        </p:spPr>
+        <p:txBody>
+          <a:bodyPr wrap="square">
+            <a:spAutoFit/>
+          </a:bodyPr>
+          <a:lstStyle/>
+          <a:p>
+            <a:pPr algn="ctr"/>
+            <a:r>
+              <a:rPr lang="fr-FR" b="1" dirty="0"/>
+              <a:t>B01 à B08</a:t>
+            </a:r>
+          </a:p>
+        </p:txBody>
+      </p:sp>
+      <p:sp>
+        <p:nvSpPr>
+          <p:cNvPr id="32" name="ZoneTexte 31">
+            <a:extLst>
+              <a:ext uri="{FF2B5EF4-FFF2-40B4-BE49-F238E27FC236}">
+                <a16:creationId xmlns:a16="http://schemas.microsoft.com/office/drawing/2014/main" id="{2A7DC8C6-8362-D8DD-44CF-269386D21154}"/>
+              </a:ext>
+            </a:extLst>
+          </p:cNvPr>
+          <p:cNvSpPr txBox="1"/>
+          <p:nvPr/>
+        </p:nvSpPr>
+        <p:spPr>
+          <a:xfrm>
+            <a:off x="3134745" y="2077435"/>
+            <a:ext cx="1604804" cy="369332"/>
+          </a:xfrm>
+          <a:prstGeom prst="rect">
+            <a:avLst/>
+          </a:prstGeom>
+          <a:noFill/>
+        </p:spPr>
+        <p:txBody>
+          <a:bodyPr wrap="square">
+            <a:spAutoFit/>
+          </a:bodyPr>
+          <a:lstStyle/>
+          <a:p>
+            <a:pPr algn="ctr"/>
+            <a:r>
+              <a:rPr lang="fr-FR" b="1" dirty="0"/>
+              <a:t>B09 à B16</a:t>
+            </a:r>
+          </a:p>
+        </p:txBody>
+      </p:sp>
+      <p:sp>
+        <p:nvSpPr>
+          <p:cNvPr id="34" name="ZoneTexte 33">
+            <a:extLst>
+              <a:ext uri="{FF2B5EF4-FFF2-40B4-BE49-F238E27FC236}">
+                <a16:creationId xmlns:a16="http://schemas.microsoft.com/office/drawing/2014/main" id="{1FB1B848-789F-7CC9-233E-C4D09DE6ED64}"/>
+              </a:ext>
+            </a:extLst>
+          </p:cNvPr>
+          <p:cNvSpPr txBox="1"/>
+          <p:nvPr/>
+        </p:nvSpPr>
+        <p:spPr>
+          <a:xfrm>
+            <a:off x="270543" y="2558355"/>
+            <a:ext cx="821305" cy="261610"/>
+          </a:xfrm>
+          <a:prstGeom prst="rect">
+            <a:avLst/>
+          </a:prstGeom>
+          <a:noFill/>
+        </p:spPr>
+        <p:txBody>
+          <a:bodyPr wrap="square">
+            <a:spAutoFit/>
+          </a:bodyPr>
+          <a:lstStyle/>
+          <a:p>
+            <a:pPr algn="ctr"/>
+            <a:r>
+              <a:rPr lang="fr-FR" sz="1100" dirty="0"/>
+              <a:t>Séance 1</a:t>
+            </a:r>
+          </a:p>
+        </p:txBody>
+      </p:sp>
+      <p:sp>
+        <p:nvSpPr>
+          <p:cNvPr id="43" name="ZoneTexte 42">
+            <a:extLst>
+              <a:ext uri="{FF2B5EF4-FFF2-40B4-BE49-F238E27FC236}">
+                <a16:creationId xmlns:a16="http://schemas.microsoft.com/office/drawing/2014/main" id="{C7A6F760-1C01-19AE-82F7-08659E0EDBFE}"/>
+              </a:ext>
+            </a:extLst>
+          </p:cNvPr>
+          <p:cNvSpPr txBox="1"/>
+          <p:nvPr/>
+        </p:nvSpPr>
+        <p:spPr>
+          <a:xfrm>
+            <a:off x="263322" y="2891111"/>
+            <a:ext cx="821305" cy="261610"/>
+          </a:xfrm>
+          <a:prstGeom prst="rect">
+            <a:avLst/>
+          </a:prstGeom>
+          <a:noFill/>
+        </p:spPr>
+        <p:txBody>
+          <a:bodyPr wrap="square">
+            <a:spAutoFit/>
+          </a:bodyPr>
+          <a:lstStyle/>
+          <a:p>
+            <a:pPr algn="ctr"/>
+            <a:r>
+              <a:rPr lang="fr-FR" sz="1100" dirty="0"/>
+              <a:t>Séance 2</a:t>
+            </a:r>
+          </a:p>
+        </p:txBody>
+      </p:sp>
+      <p:sp>
+        <p:nvSpPr>
+          <p:cNvPr id="45" name="ZoneTexte 44">
+            <a:extLst>
+              <a:ext uri="{FF2B5EF4-FFF2-40B4-BE49-F238E27FC236}">
+                <a16:creationId xmlns:a16="http://schemas.microsoft.com/office/drawing/2014/main" id="{347361E2-CD17-E827-87D6-274A909955D1}"/>
+              </a:ext>
+            </a:extLst>
+          </p:cNvPr>
+          <p:cNvSpPr txBox="1"/>
+          <p:nvPr/>
+        </p:nvSpPr>
+        <p:spPr>
+          <a:xfrm>
+            <a:off x="270543" y="3443670"/>
+            <a:ext cx="821305" cy="261610"/>
+          </a:xfrm>
+          <a:prstGeom prst="rect">
+            <a:avLst/>
+          </a:prstGeom>
+          <a:noFill/>
+        </p:spPr>
+        <p:txBody>
+          <a:bodyPr wrap="square">
+            <a:spAutoFit/>
+          </a:bodyPr>
+          <a:lstStyle/>
+          <a:p>
+            <a:pPr algn="ctr"/>
+            <a:r>
+              <a:rPr lang="fr-FR" sz="1100" dirty="0"/>
+              <a:t>Séance 3</a:t>
+            </a:r>
+          </a:p>
+        </p:txBody>
+      </p:sp>
+      <p:sp>
+        <p:nvSpPr>
+          <p:cNvPr id="47" name="ZoneTexte 46">
+            <a:extLst>
+              <a:ext uri="{FF2B5EF4-FFF2-40B4-BE49-F238E27FC236}">
+                <a16:creationId xmlns:a16="http://schemas.microsoft.com/office/drawing/2014/main" id="{1AE1C8AF-D6DD-7081-FB67-E5A8A16FCAEF}"/>
+              </a:ext>
+            </a:extLst>
+          </p:cNvPr>
+          <p:cNvSpPr txBox="1"/>
+          <p:nvPr/>
+        </p:nvSpPr>
+        <p:spPr>
+          <a:xfrm>
+            <a:off x="270543" y="3824533"/>
+            <a:ext cx="821305" cy="261610"/>
+          </a:xfrm>
+          <a:prstGeom prst="rect">
+            <a:avLst/>
+          </a:prstGeom>
+          <a:noFill/>
+        </p:spPr>
+        <p:txBody>
+          <a:bodyPr wrap="square">
+            <a:spAutoFit/>
+          </a:bodyPr>
+          <a:lstStyle/>
+          <a:p>
+            <a:pPr algn="ctr"/>
+            <a:r>
+              <a:rPr lang="fr-FR" sz="1100" dirty="0"/>
+              <a:t>Séance 4</a:t>
+            </a:r>
+          </a:p>
+        </p:txBody>
+      </p:sp>
+      <p:sp>
+        <p:nvSpPr>
+          <p:cNvPr id="48" name="ZoneTexte 47">
+            <a:extLst>
+              <a:ext uri="{FF2B5EF4-FFF2-40B4-BE49-F238E27FC236}">
+                <a16:creationId xmlns:a16="http://schemas.microsoft.com/office/drawing/2014/main" id="{322908FF-432D-5A05-837E-CBF1C04C2393}"/>
+              </a:ext>
+            </a:extLst>
+          </p:cNvPr>
+          <p:cNvSpPr txBox="1"/>
+          <p:nvPr/>
+        </p:nvSpPr>
+        <p:spPr>
+          <a:xfrm>
+            <a:off x="287897" y="4352300"/>
+            <a:ext cx="821305" cy="261610"/>
+          </a:xfrm>
+          <a:prstGeom prst="rect">
+            <a:avLst/>
+          </a:prstGeom>
+          <a:noFill/>
+        </p:spPr>
+        <p:txBody>
+          <a:bodyPr wrap="square">
+            <a:spAutoFit/>
+          </a:bodyPr>
+          <a:lstStyle/>
+          <a:p>
+            <a:pPr algn="ctr"/>
+            <a:r>
+              <a:rPr lang="fr-FR" sz="1100" dirty="0"/>
+              <a:t>Séance 5</a:t>
+            </a:r>
+          </a:p>
+        </p:txBody>
+      </p:sp>
+      <p:sp>
+        <p:nvSpPr>
+          <p:cNvPr id="49" name="ZoneTexte 48">
+            <a:extLst>
+              <a:ext uri="{FF2B5EF4-FFF2-40B4-BE49-F238E27FC236}">
+                <a16:creationId xmlns:a16="http://schemas.microsoft.com/office/drawing/2014/main" id="{97DBFDDF-72BF-A430-CD97-8AE4CE4D7C61}"/>
+              </a:ext>
+            </a:extLst>
+          </p:cNvPr>
+          <p:cNvSpPr txBox="1"/>
+          <p:nvPr/>
+        </p:nvSpPr>
+        <p:spPr>
+          <a:xfrm>
+            <a:off x="282020" y="4723123"/>
+            <a:ext cx="821305" cy="261610"/>
+          </a:xfrm>
+          <a:prstGeom prst="rect">
+            <a:avLst/>
+          </a:prstGeom>
+          <a:noFill/>
+        </p:spPr>
+        <p:txBody>
+          <a:bodyPr wrap="square">
+            <a:spAutoFit/>
+          </a:bodyPr>
+          <a:lstStyle/>
+          <a:p>
+            <a:pPr algn="ctr"/>
+            <a:r>
+              <a:rPr lang="fr-FR" sz="1100" dirty="0"/>
+              <a:t>Séance 6</a:t>
+            </a:r>
+          </a:p>
+        </p:txBody>
+      </p:sp>
+      <p:pic>
+        <p:nvPicPr>
+          <p:cNvPr id="25" name="Image 24"/>
+          <p:cNvPicPr>
+            <a:picLocks noChangeAspect="1"/>
+          </p:cNvPicPr>
+          <p:nvPr/>
+        </p:nvPicPr>
+        <p:blipFill>
+          <a:blip r:embed="rId3">
+            <a:extLst>
+              <a:ext uri="{28A0092B-C50C-407E-A947-70E740481C1C}">
+                <a14:useLocalDpi xmlns:a14="http://schemas.microsoft.com/office/drawing/2010/main" val="0"/>
+              </a:ext>
+            </a:extLst>
+          </a:blip>
+          <a:stretch>
+            <a:fillRect/>
+          </a:stretch>
+        </p:blipFill>
+        <p:spPr>
+          <a:xfrm>
+            <a:off x="9643587" y="452685"/>
+            <a:ext cx="2050702" cy="842404"/>
+          </a:xfrm>
+          <a:prstGeom prst="rect">
+            <a:avLst/>
+          </a:prstGeom>
+        </p:spPr>
+      </p:pic>
+      <p:sp>
+        <p:nvSpPr>
+          <p:cNvPr id="5" name="Rectangle 4">
+            <a:extLst>
+              <a:ext uri="{FF2B5EF4-FFF2-40B4-BE49-F238E27FC236}">
+                <a16:creationId xmlns:a16="http://schemas.microsoft.com/office/drawing/2014/main" id="{B4B8254A-7A68-64C8-9294-6854DD6C3171}"/>
               </a:ext>
             </a:extLst>
           </p:cNvPr>
@@ -14318,8 +14636,8 @@
         </p:nvSpPr>
         <p:spPr>
           <a:xfrm>
-            <a:off x="1354395" y="3785859"/>
-            <a:ext cx="1604804" cy="350520"/>
+            <a:off x="3988093" y="2513900"/>
+            <a:ext cx="751454" cy="350520"/>
           </a:xfrm>
           <a:prstGeom prst="rect">
             <a:avLst/>
@@ -14353,7 +14671,7 @@
           <a:p>
             <a:pPr algn="ctr"/>
             <a:r>
-              <a:rPr lang="fr-FR" sz="1600" b="1" dirty="0"/>
+              <a:rPr lang="fr-FR" sz="1400" b="1" dirty="0"/>
               <a:t>TP VI2</a:t>
             </a:r>
           </a:p>
@@ -14361,10 +14679,10 @@
       </p:sp>
       <p:sp>
         <p:nvSpPr>
-          <p:cNvPr id="18" name="Rectangle 17">
-            <a:extLst>
-              <a:ext uri="{FF2B5EF4-FFF2-40B4-BE49-F238E27FC236}">
-                <a16:creationId xmlns:a16="http://schemas.microsoft.com/office/drawing/2014/main" id="{67DB11C6-E438-64D0-8289-EA27977E12F7}"/>
+          <p:cNvPr id="8" name="Rectangle 7">
+            <a:extLst>
+              <a:ext uri="{FF2B5EF4-FFF2-40B4-BE49-F238E27FC236}">
+                <a16:creationId xmlns:a16="http://schemas.microsoft.com/office/drawing/2014/main" id="{1DEA2F91-D546-EF69-5821-13B24A72A1BC}"/>
               </a:ext>
             </a:extLst>
           </p:cNvPr>
@@ -14373,14 +14691,14 @@
         </p:nvSpPr>
         <p:spPr>
           <a:xfrm>
-            <a:off x="3134746" y="3402867"/>
-            <a:ext cx="1604804" cy="350520"/>
+            <a:off x="3134745" y="2895282"/>
+            <a:ext cx="751454" cy="350520"/>
           </a:xfrm>
           <a:prstGeom prst="rect">
             <a:avLst/>
           </a:prstGeom>
           <a:solidFill>
-            <a:srgbClr val="002060"/>
+            <a:schemeClr val="accent2"/>
           </a:solidFill>
           <a:ln>
             <a:noFill/>
@@ -14408,18 +14726,18 @@
           <a:p>
             <a:pPr algn="ctr"/>
             <a:r>
-              <a:rPr lang="fr-FR" sz="1600" b="1" dirty="0"/>
-              <a:t>TP1</a:t>
-            </a:r>
-          </a:p>
-        </p:txBody>
-      </p:sp>
-      <p:sp>
-        <p:nvSpPr>
-          <p:cNvPr id="24" name="Rectangle 23">
-            <a:extLst>
-              <a:ext uri="{FF2B5EF4-FFF2-40B4-BE49-F238E27FC236}">
-                <a16:creationId xmlns:a16="http://schemas.microsoft.com/office/drawing/2014/main" id="{5890B81A-9B60-BD6E-D526-CE952E97E6D8}"/>
+              <a:rPr lang="fr-FR" sz="1400" b="1" dirty="0"/>
+              <a:t>TP VI2</a:t>
+            </a:r>
+          </a:p>
+        </p:txBody>
+      </p:sp>
+      <p:sp>
+        <p:nvSpPr>
+          <p:cNvPr id="10" name="Rectangle 9">
+            <a:extLst>
+              <a:ext uri="{FF2B5EF4-FFF2-40B4-BE49-F238E27FC236}">
+                <a16:creationId xmlns:a16="http://schemas.microsoft.com/office/drawing/2014/main" id="{81CA1916-A585-796E-8407-D490918B16DB}"/>
               </a:ext>
             </a:extLst>
           </p:cNvPr>
@@ -14428,14 +14746,14 @@
         </p:nvSpPr>
         <p:spPr>
           <a:xfrm>
-            <a:off x="3134746" y="3780078"/>
-            <a:ext cx="1604804" cy="350520"/>
+            <a:off x="3988093" y="2898676"/>
+            <a:ext cx="751454" cy="350520"/>
           </a:xfrm>
           <a:prstGeom prst="rect">
             <a:avLst/>
           </a:prstGeom>
           <a:solidFill>
-            <a:srgbClr val="002060"/>
+            <a:schemeClr val="accent2"/>
           </a:solidFill>
           <a:ln>
             <a:noFill/>
@@ -14463,330 +14781,400 @@
           <a:p>
             <a:pPr algn="ctr"/>
             <a:r>
-              <a:rPr lang="fr-FR" sz="1600" b="1" dirty="0"/>
-              <a:t>TP2</a:t>
-            </a:r>
-          </a:p>
-        </p:txBody>
-      </p:sp>
-      <p:sp>
-        <p:nvSpPr>
-          <p:cNvPr id="26" name="ZoneTexte 25">
-            <a:extLst>
-              <a:ext uri="{FF2B5EF4-FFF2-40B4-BE49-F238E27FC236}">
-                <a16:creationId xmlns:a16="http://schemas.microsoft.com/office/drawing/2014/main" id="{8604DACB-DF23-40CE-1944-F1D33C96E0FF}"/>
-              </a:ext>
-            </a:extLst>
-          </p:cNvPr>
-          <p:cNvSpPr txBox="1"/>
-          <p:nvPr/>
-        </p:nvSpPr>
-        <p:spPr>
-          <a:xfrm>
-            <a:off x="1354394" y="2077435"/>
-            <a:ext cx="1604804" cy="369332"/>
-          </a:xfrm>
-          <a:prstGeom prst="rect">
-            <a:avLst/>
-          </a:prstGeom>
-          <a:noFill/>
-        </p:spPr>
-        <p:txBody>
-          <a:bodyPr wrap="square">
-            <a:spAutoFit/>
-          </a:bodyPr>
+              <a:rPr lang="fr-FR" sz="1400" b="1" dirty="0"/>
+              <a:t>TP VI1</a:t>
+            </a:r>
+          </a:p>
+        </p:txBody>
+      </p:sp>
+      <p:sp>
+        <p:nvSpPr>
+          <p:cNvPr id="16" name="Rectangle 15">
+            <a:extLst>
+              <a:ext uri="{FF2B5EF4-FFF2-40B4-BE49-F238E27FC236}">
+                <a16:creationId xmlns:a16="http://schemas.microsoft.com/office/drawing/2014/main" id="{D4013EFB-91C1-5B7B-B9EA-74E34D7FFC49}"/>
+              </a:ext>
+            </a:extLst>
+          </p:cNvPr>
+          <p:cNvSpPr/>
+          <p:nvPr/>
+        </p:nvSpPr>
+        <p:spPr>
+          <a:xfrm>
+            <a:off x="1354394" y="3402867"/>
+            <a:ext cx="751454" cy="350520"/>
+          </a:xfrm>
+          <a:prstGeom prst="rect">
+            <a:avLst/>
+          </a:prstGeom>
+          <a:solidFill>
+            <a:schemeClr val="accent2"/>
+          </a:solidFill>
+          <a:ln>
+            <a:noFill/>
+          </a:ln>
+        </p:spPr>
+        <p:style>
+          <a:lnRef idx="2">
+            <a:schemeClr val="accent1">
+              <a:shade val="15000"/>
+            </a:schemeClr>
+          </a:lnRef>
+          <a:fillRef idx="1">
+            <a:schemeClr val="accent1"/>
+          </a:fillRef>
+          <a:effectRef idx="0">
+            <a:schemeClr val="accent1"/>
+          </a:effectRef>
+          <a:fontRef idx="minor">
+            <a:schemeClr val="lt1"/>
+          </a:fontRef>
+        </p:style>
+        <p:txBody>
+          <a:bodyPr rtlCol="0" anchor="ctr"/>
           <a:lstStyle/>
           <a:p>
             <a:pPr algn="ctr"/>
             <a:r>
-              <a:rPr lang="fr-FR" b="1" dirty="0"/>
-              <a:t>B01 à B08</a:t>
-            </a:r>
-          </a:p>
-        </p:txBody>
-      </p:sp>
-      <p:sp>
-        <p:nvSpPr>
-          <p:cNvPr id="32" name="ZoneTexte 31">
-            <a:extLst>
-              <a:ext uri="{FF2B5EF4-FFF2-40B4-BE49-F238E27FC236}">
-                <a16:creationId xmlns:a16="http://schemas.microsoft.com/office/drawing/2014/main" id="{2A7DC8C6-8362-D8DD-44CF-269386D21154}"/>
-              </a:ext>
-            </a:extLst>
-          </p:cNvPr>
-          <p:cNvSpPr txBox="1"/>
-          <p:nvPr/>
-        </p:nvSpPr>
-        <p:spPr>
-          <a:xfrm>
-            <a:off x="3134745" y="2077435"/>
-            <a:ext cx="1604804" cy="369332"/>
-          </a:xfrm>
-          <a:prstGeom prst="rect">
-            <a:avLst/>
-          </a:prstGeom>
-          <a:noFill/>
-        </p:spPr>
-        <p:txBody>
-          <a:bodyPr wrap="square">
-            <a:spAutoFit/>
-          </a:bodyPr>
+              <a:rPr lang="fr-FR" sz="1400" b="1" dirty="0"/>
+              <a:t>TP VI1</a:t>
+            </a:r>
+          </a:p>
+        </p:txBody>
+      </p:sp>
+      <p:sp>
+        <p:nvSpPr>
+          <p:cNvPr id="19" name="Rectangle 18">
+            <a:extLst>
+              <a:ext uri="{FF2B5EF4-FFF2-40B4-BE49-F238E27FC236}">
+                <a16:creationId xmlns:a16="http://schemas.microsoft.com/office/drawing/2014/main" id="{9B4DD4F3-C0C1-5BF8-9A9A-07C806621681}"/>
+              </a:ext>
+            </a:extLst>
+          </p:cNvPr>
+          <p:cNvSpPr/>
+          <p:nvPr/>
+        </p:nvSpPr>
+        <p:spPr>
+          <a:xfrm>
+            <a:off x="2207740" y="3402867"/>
+            <a:ext cx="751454" cy="350520"/>
+          </a:xfrm>
+          <a:prstGeom prst="rect">
+            <a:avLst/>
+          </a:prstGeom>
+          <a:solidFill>
+            <a:schemeClr val="accent2"/>
+          </a:solidFill>
+          <a:ln>
+            <a:noFill/>
+          </a:ln>
+        </p:spPr>
+        <p:style>
+          <a:lnRef idx="2">
+            <a:schemeClr val="accent1">
+              <a:shade val="15000"/>
+            </a:schemeClr>
+          </a:lnRef>
+          <a:fillRef idx="1">
+            <a:schemeClr val="accent1"/>
+          </a:fillRef>
+          <a:effectRef idx="0">
+            <a:schemeClr val="accent1"/>
+          </a:effectRef>
+          <a:fontRef idx="minor">
+            <a:schemeClr val="lt1"/>
+          </a:fontRef>
+        </p:style>
+        <p:txBody>
+          <a:bodyPr rtlCol="0" anchor="ctr"/>
           <a:lstStyle/>
           <a:p>
             <a:pPr algn="ctr"/>
             <a:r>
-              <a:rPr lang="fr-FR" b="1" dirty="0"/>
-              <a:t>B09 à B16</a:t>
-            </a:r>
-          </a:p>
-        </p:txBody>
-      </p:sp>
-      <p:sp>
-        <p:nvSpPr>
-          <p:cNvPr id="34" name="ZoneTexte 33">
-            <a:extLst>
-              <a:ext uri="{FF2B5EF4-FFF2-40B4-BE49-F238E27FC236}">
-                <a16:creationId xmlns:a16="http://schemas.microsoft.com/office/drawing/2014/main" id="{1FB1B848-789F-7CC9-233E-C4D09DE6ED64}"/>
-              </a:ext>
-            </a:extLst>
-          </p:cNvPr>
-          <p:cNvSpPr txBox="1"/>
-          <p:nvPr/>
-        </p:nvSpPr>
-        <p:spPr>
-          <a:xfrm>
-            <a:off x="270543" y="2558355"/>
-            <a:ext cx="821305" cy="261610"/>
-          </a:xfrm>
-          <a:prstGeom prst="rect">
-            <a:avLst/>
-          </a:prstGeom>
-          <a:noFill/>
-        </p:spPr>
-        <p:txBody>
-          <a:bodyPr wrap="square">
-            <a:spAutoFit/>
-          </a:bodyPr>
+              <a:rPr lang="fr-FR" sz="1400" b="1" dirty="0"/>
+              <a:t>TP VI2</a:t>
+            </a:r>
+          </a:p>
+        </p:txBody>
+      </p:sp>
+      <p:sp>
+        <p:nvSpPr>
+          <p:cNvPr id="21" name="Rectangle 20">
+            <a:extLst>
+              <a:ext uri="{FF2B5EF4-FFF2-40B4-BE49-F238E27FC236}">
+                <a16:creationId xmlns:a16="http://schemas.microsoft.com/office/drawing/2014/main" id="{9E613C2A-3B60-42C1-A582-45C98751D56A}"/>
+              </a:ext>
+            </a:extLst>
+          </p:cNvPr>
+          <p:cNvSpPr/>
+          <p:nvPr/>
+        </p:nvSpPr>
+        <p:spPr>
+          <a:xfrm>
+            <a:off x="1354392" y="3784249"/>
+            <a:ext cx="751454" cy="350520"/>
+          </a:xfrm>
+          <a:prstGeom prst="rect">
+            <a:avLst/>
+          </a:prstGeom>
+          <a:solidFill>
+            <a:schemeClr val="accent2"/>
+          </a:solidFill>
+          <a:ln>
+            <a:noFill/>
+          </a:ln>
+        </p:spPr>
+        <p:style>
+          <a:lnRef idx="2">
+            <a:schemeClr val="accent1">
+              <a:shade val="15000"/>
+            </a:schemeClr>
+          </a:lnRef>
+          <a:fillRef idx="1">
+            <a:schemeClr val="accent1"/>
+          </a:fillRef>
+          <a:effectRef idx="0">
+            <a:schemeClr val="accent1"/>
+          </a:effectRef>
+          <a:fontRef idx="minor">
+            <a:schemeClr val="lt1"/>
+          </a:fontRef>
+        </p:style>
+        <p:txBody>
+          <a:bodyPr rtlCol="0" anchor="ctr"/>
           <a:lstStyle/>
           <a:p>
             <a:pPr algn="ctr"/>
             <a:r>
-              <a:rPr lang="fr-FR" sz="1100" dirty="0"/>
-              <a:t>Séance 1</a:t>
-            </a:r>
-          </a:p>
-        </p:txBody>
-      </p:sp>
-      <p:sp>
-        <p:nvSpPr>
-          <p:cNvPr id="43" name="ZoneTexte 42">
-            <a:extLst>
-              <a:ext uri="{FF2B5EF4-FFF2-40B4-BE49-F238E27FC236}">
-                <a16:creationId xmlns:a16="http://schemas.microsoft.com/office/drawing/2014/main" id="{C7A6F760-1C01-19AE-82F7-08659E0EDBFE}"/>
-              </a:ext>
-            </a:extLst>
-          </p:cNvPr>
-          <p:cNvSpPr txBox="1"/>
-          <p:nvPr/>
-        </p:nvSpPr>
-        <p:spPr>
-          <a:xfrm>
-            <a:off x="263322" y="2891111"/>
-            <a:ext cx="821305" cy="261610"/>
-          </a:xfrm>
-          <a:prstGeom prst="rect">
-            <a:avLst/>
-          </a:prstGeom>
-          <a:noFill/>
-        </p:spPr>
-        <p:txBody>
-          <a:bodyPr wrap="square">
-            <a:spAutoFit/>
-          </a:bodyPr>
+              <a:rPr lang="fr-FR" sz="1400" b="1" dirty="0"/>
+              <a:t>TP VI2</a:t>
+            </a:r>
+          </a:p>
+        </p:txBody>
+      </p:sp>
+      <p:sp>
+        <p:nvSpPr>
+          <p:cNvPr id="27" name="Rectangle 26">
+            <a:extLst>
+              <a:ext uri="{FF2B5EF4-FFF2-40B4-BE49-F238E27FC236}">
+                <a16:creationId xmlns:a16="http://schemas.microsoft.com/office/drawing/2014/main" id="{04370ED9-B96E-F7FB-652B-00D951148AFF}"/>
+              </a:ext>
+            </a:extLst>
+          </p:cNvPr>
+          <p:cNvSpPr/>
+          <p:nvPr/>
+        </p:nvSpPr>
+        <p:spPr>
+          <a:xfrm>
+            <a:off x="2207740" y="3787643"/>
+            <a:ext cx="751454" cy="350520"/>
+          </a:xfrm>
+          <a:prstGeom prst="rect">
+            <a:avLst/>
+          </a:prstGeom>
+          <a:solidFill>
+            <a:schemeClr val="accent2"/>
+          </a:solidFill>
+          <a:ln>
+            <a:noFill/>
+          </a:ln>
+        </p:spPr>
+        <p:style>
+          <a:lnRef idx="2">
+            <a:schemeClr val="accent1">
+              <a:shade val="15000"/>
+            </a:schemeClr>
+          </a:lnRef>
+          <a:fillRef idx="1">
+            <a:schemeClr val="accent1"/>
+          </a:fillRef>
+          <a:effectRef idx="0">
+            <a:schemeClr val="accent1"/>
+          </a:effectRef>
+          <a:fontRef idx="minor">
+            <a:schemeClr val="lt1"/>
+          </a:fontRef>
+        </p:style>
+        <p:txBody>
+          <a:bodyPr rtlCol="0" anchor="ctr"/>
           <a:lstStyle/>
           <a:p>
             <a:pPr algn="ctr"/>
             <a:r>
-              <a:rPr lang="fr-FR" sz="1100" dirty="0"/>
-              <a:t>Séance 2</a:t>
-            </a:r>
-          </a:p>
-        </p:txBody>
-      </p:sp>
-      <p:sp>
-        <p:nvSpPr>
-          <p:cNvPr id="45" name="ZoneTexte 44">
-            <a:extLst>
-              <a:ext uri="{FF2B5EF4-FFF2-40B4-BE49-F238E27FC236}">
-                <a16:creationId xmlns:a16="http://schemas.microsoft.com/office/drawing/2014/main" id="{347361E2-CD17-E827-87D6-274A909955D1}"/>
-              </a:ext>
-            </a:extLst>
-          </p:cNvPr>
-          <p:cNvSpPr txBox="1"/>
-          <p:nvPr/>
-        </p:nvSpPr>
-        <p:spPr>
-          <a:xfrm>
-            <a:off x="270543" y="3443670"/>
-            <a:ext cx="821305" cy="261610"/>
-          </a:xfrm>
-          <a:prstGeom prst="rect">
-            <a:avLst/>
-          </a:prstGeom>
-          <a:noFill/>
-        </p:spPr>
-        <p:txBody>
-          <a:bodyPr wrap="square">
-            <a:spAutoFit/>
-          </a:bodyPr>
+              <a:rPr lang="fr-FR" sz="1400" b="1" dirty="0"/>
+              <a:t>TP VI1</a:t>
+            </a:r>
+          </a:p>
+        </p:txBody>
+      </p:sp>
+      <p:sp>
+        <p:nvSpPr>
+          <p:cNvPr id="30" name="Rectangle 29">
+            <a:extLst>
+              <a:ext uri="{FF2B5EF4-FFF2-40B4-BE49-F238E27FC236}">
+                <a16:creationId xmlns:a16="http://schemas.microsoft.com/office/drawing/2014/main" id="{A3ED2499-703C-181D-DF4A-673322051F1D}"/>
+              </a:ext>
+            </a:extLst>
+          </p:cNvPr>
+          <p:cNvSpPr/>
+          <p:nvPr/>
+        </p:nvSpPr>
+        <p:spPr>
+          <a:xfrm>
+            <a:off x="5090292" y="2513900"/>
+            <a:ext cx="1356298" cy="1624263"/>
+          </a:xfrm>
+          <a:prstGeom prst="rect">
+            <a:avLst/>
+          </a:prstGeom>
+          <a:solidFill>
+            <a:srgbClr val="00B0F0"/>
+          </a:solidFill>
+        </p:spPr>
+        <p:style>
+          <a:lnRef idx="2">
+            <a:schemeClr val="accent1">
+              <a:shade val="15000"/>
+            </a:schemeClr>
+          </a:lnRef>
+          <a:fillRef idx="1">
+            <a:schemeClr val="accent1"/>
+          </a:fillRef>
+          <a:effectRef idx="0">
+            <a:schemeClr val="accent1"/>
+          </a:effectRef>
+          <a:fontRef idx="minor">
+            <a:schemeClr val="lt1"/>
+          </a:fontRef>
+        </p:style>
+        <p:txBody>
+          <a:bodyPr rtlCol="0" anchor="ctr"/>
           <a:lstStyle/>
           <a:p>
             <a:pPr algn="ctr"/>
             <a:r>
-              <a:rPr lang="fr-FR" sz="1100" dirty="0"/>
-              <a:t>Séance 3</a:t>
-            </a:r>
-          </a:p>
-        </p:txBody>
-      </p:sp>
-      <p:sp>
-        <p:nvSpPr>
-          <p:cNvPr id="47" name="ZoneTexte 46">
-            <a:extLst>
-              <a:ext uri="{FF2B5EF4-FFF2-40B4-BE49-F238E27FC236}">
-                <a16:creationId xmlns:a16="http://schemas.microsoft.com/office/drawing/2014/main" id="{1AE1C8AF-D6DD-7081-FB67-E5A8A16FCAEF}"/>
-              </a:ext>
-            </a:extLst>
-          </p:cNvPr>
-          <p:cNvSpPr txBox="1"/>
-          <p:nvPr/>
-        </p:nvSpPr>
-        <p:spPr>
-          <a:xfrm>
-            <a:off x="270543" y="3824533"/>
-            <a:ext cx="821305" cy="261610"/>
-          </a:xfrm>
-          <a:prstGeom prst="rect">
-            <a:avLst/>
-          </a:prstGeom>
-          <a:noFill/>
-        </p:spPr>
-        <p:txBody>
-          <a:bodyPr wrap="square">
-            <a:spAutoFit/>
-          </a:bodyPr>
+              <a:rPr lang="fr-FR" sz="1600" dirty="0">
+                <a:solidFill>
+                  <a:schemeClr val="bg1"/>
+                </a:solidFill>
+              </a:rPr>
+              <a:t>Feuille de résultats</a:t>
+            </a:r>
+          </a:p>
+        </p:txBody>
+      </p:sp>
+      <p:sp>
+        <p:nvSpPr>
+          <p:cNvPr id="33" name="Rectangle 32">
+            <a:extLst>
+              <a:ext uri="{FF2B5EF4-FFF2-40B4-BE49-F238E27FC236}">
+                <a16:creationId xmlns:a16="http://schemas.microsoft.com/office/drawing/2014/main" id="{A83C895C-8371-E583-DA83-2DFB64F2BBF5}"/>
+              </a:ext>
+            </a:extLst>
+          </p:cNvPr>
+          <p:cNvSpPr/>
+          <p:nvPr/>
+        </p:nvSpPr>
+        <p:spPr>
+          <a:xfrm>
+            <a:off x="5090292" y="4303395"/>
+            <a:ext cx="1356298" cy="350520"/>
+          </a:xfrm>
+          <a:prstGeom prst="rect">
+            <a:avLst/>
+          </a:prstGeom>
+          <a:solidFill>
+            <a:srgbClr val="00B0F0"/>
+          </a:solidFill>
+        </p:spPr>
+        <p:style>
+          <a:lnRef idx="2">
+            <a:schemeClr val="accent1">
+              <a:shade val="15000"/>
+            </a:schemeClr>
+          </a:lnRef>
+          <a:fillRef idx="1">
+            <a:schemeClr val="accent1"/>
+          </a:fillRef>
+          <a:effectRef idx="0">
+            <a:schemeClr val="accent1"/>
+          </a:effectRef>
+          <a:fontRef idx="minor">
+            <a:schemeClr val="lt1"/>
+          </a:fontRef>
+        </p:style>
+        <p:txBody>
+          <a:bodyPr rtlCol="0" anchor="ctr"/>
           <a:lstStyle/>
           <a:p>
             <a:pPr algn="ctr"/>
             <a:r>
-              <a:rPr lang="fr-FR" sz="1100" dirty="0"/>
-              <a:t>Séance 4</a:t>
-            </a:r>
-          </a:p>
-        </p:txBody>
-      </p:sp>
-      <p:sp>
-        <p:nvSpPr>
-          <p:cNvPr id="48" name="ZoneTexte 47">
-            <a:extLst>
-              <a:ext uri="{FF2B5EF4-FFF2-40B4-BE49-F238E27FC236}">
-                <a16:creationId xmlns:a16="http://schemas.microsoft.com/office/drawing/2014/main" id="{322908FF-432D-5A05-837E-CBF1C04C2393}"/>
-              </a:ext>
-            </a:extLst>
-          </p:cNvPr>
-          <p:cNvSpPr txBox="1"/>
-          <p:nvPr/>
-        </p:nvSpPr>
-        <p:spPr>
-          <a:xfrm>
-            <a:off x="287897" y="4352300"/>
-            <a:ext cx="821305" cy="261610"/>
-          </a:xfrm>
-          <a:prstGeom prst="rect">
-            <a:avLst/>
-          </a:prstGeom>
-          <a:noFill/>
-        </p:spPr>
-        <p:txBody>
-          <a:bodyPr wrap="square">
-            <a:spAutoFit/>
-          </a:bodyPr>
+              <a:rPr lang="fr-FR" sz="1100" dirty="0">
+                <a:solidFill>
+                  <a:schemeClr val="bg1"/>
+                </a:solidFill>
+              </a:rPr>
+              <a:t>Analyse comparative</a:t>
+            </a:r>
+          </a:p>
+        </p:txBody>
+      </p:sp>
+      <p:sp>
+        <p:nvSpPr>
+          <p:cNvPr id="37" name="Rectangle 36">
+            <a:extLst>
+              <a:ext uri="{FF2B5EF4-FFF2-40B4-BE49-F238E27FC236}">
+                <a16:creationId xmlns:a16="http://schemas.microsoft.com/office/drawing/2014/main" id="{EBA05CAD-D4CC-5C0A-9FA8-088AA6D8167C}"/>
+              </a:ext>
+            </a:extLst>
+          </p:cNvPr>
+          <p:cNvSpPr/>
+          <p:nvPr/>
+        </p:nvSpPr>
+        <p:spPr>
+          <a:xfrm>
+            <a:off x="5090292" y="4697730"/>
+            <a:ext cx="1356298" cy="350520"/>
+          </a:xfrm>
+          <a:prstGeom prst="rect">
+            <a:avLst/>
+          </a:prstGeom>
+          <a:solidFill>
+            <a:srgbClr val="00B0F0"/>
+          </a:solidFill>
+        </p:spPr>
+        <p:style>
+          <a:lnRef idx="2">
+            <a:schemeClr val="accent1">
+              <a:shade val="15000"/>
+            </a:schemeClr>
+          </a:lnRef>
+          <a:fillRef idx="1">
+            <a:schemeClr val="accent1"/>
+          </a:fillRef>
+          <a:effectRef idx="0">
+            <a:schemeClr val="accent1"/>
+          </a:effectRef>
+          <a:fontRef idx="minor">
+            <a:schemeClr val="lt1"/>
+          </a:fontRef>
+        </p:style>
+        <p:txBody>
+          <a:bodyPr rtlCol="0" anchor="ctr"/>
           <a:lstStyle/>
           <a:p>
             <a:pPr algn="ctr"/>
             <a:r>
-              <a:rPr lang="fr-FR" sz="1100" dirty="0"/>
-              <a:t>Séance 5</a:t>
-            </a:r>
-          </a:p>
-        </p:txBody>
-      </p:sp>
-      <p:sp>
-        <p:nvSpPr>
-          <p:cNvPr id="49" name="ZoneTexte 48">
-            <a:extLst>
-              <a:ext uri="{FF2B5EF4-FFF2-40B4-BE49-F238E27FC236}">
-                <a16:creationId xmlns:a16="http://schemas.microsoft.com/office/drawing/2014/main" id="{97DBFDDF-72BF-A430-CD97-8AE4CE4D7C61}"/>
-              </a:ext>
-            </a:extLst>
-          </p:cNvPr>
-          <p:cNvSpPr txBox="1"/>
-          <p:nvPr/>
-        </p:nvSpPr>
-        <p:spPr>
-          <a:xfrm>
-            <a:off x="282020" y="4723123"/>
-            <a:ext cx="821305" cy="261610"/>
-          </a:xfrm>
-          <a:prstGeom prst="rect">
-            <a:avLst/>
-          </a:prstGeom>
-          <a:noFill/>
-        </p:spPr>
-        <p:txBody>
-          <a:bodyPr wrap="square">
-            <a:spAutoFit/>
-          </a:bodyPr>
-          <a:lstStyle/>
-          <a:p>
-            <a:pPr algn="ctr"/>
-            <a:r>
-              <a:rPr lang="fr-FR" sz="1100" dirty="0"/>
-              <a:t>Séance 6</a:t>
-            </a:r>
-          </a:p>
-        </p:txBody>
-      </p:sp>
-      <p:pic>
-        <p:nvPicPr>
-          <p:cNvPr id="25" name="Image 24"/>
-          <p:cNvPicPr>
-            <a:picLocks noChangeAspect="1"/>
-          </p:cNvPicPr>
-          <p:nvPr/>
-        </p:nvPicPr>
-        <p:blipFill>
-          <a:blip r:embed="rId3">
-            <a:extLst>
-              <a:ext uri="{28A0092B-C50C-407E-A947-70E740481C1C}">
-                <a14:useLocalDpi xmlns:a14="http://schemas.microsoft.com/office/drawing/2010/main" val="0"/>
-              </a:ext>
-            </a:extLst>
-          </a:blip>
-          <a:stretch>
-            <a:fillRect/>
-          </a:stretch>
-        </p:blipFill>
-        <p:spPr>
-          <a:xfrm>
-            <a:off x="9643587" y="452685"/>
-            <a:ext cx="2050702" cy="842404"/>
-          </a:xfrm>
-          <a:prstGeom prst="rect">
-            <a:avLst/>
-          </a:prstGeom>
-        </p:spPr>
-      </p:pic>
+              <a:rPr lang="fr-FR" sz="1100" dirty="0">
+                <a:solidFill>
+                  <a:schemeClr val="bg1"/>
+                </a:solidFill>
+              </a:rPr>
+              <a:t>Poster</a:t>
+            </a:r>
+          </a:p>
+        </p:txBody>
+      </p:sp>
     </p:spTree>
     <p:extLst>
       <p:ext uri="{BB962C8B-B14F-4D97-AF65-F5344CB8AC3E}">

</xml_diff>